<commit_message>
Second mechanical pass over the deck
clean_deck2.py fixes the alignment drift and consistency issues found by
audit_format.py in Sandra's latest version: slide 3's kicker was out of
line with every other slide, its intro block hung left of the title, its
card gutters were uneven and its number badges straddled the card top
edge; slide 4's three body blocks sat at three different offsets and two
heights; slide 7's closing line was 0.02in off the margin.

Text: two stray hyphens changed to en dashes, one trailing space, a
missing article, and 'Operational Buy In' to sentence case with a
hyphen to match its sibling headings.

A word-level diff against the input confirms the only vocabulary change
is Buy In to buy-in. The slide 5 title, the empty lower thirds on
slides 4 and 7, and list punctuation style are untouched as content
decisions.

Co-Authored-By: Claude Opus 5 <noreply@anthropic.com>
Claude-Session: https://claude.ai/code/session_01USX9SeNWtCVt7CViGP813v
</commit_message>
<xml_diff>
--- a/briefings/Codi_Presentation_Sandra_Vermaak_clean.pptx
+++ b/briefings/Codi_Presentation_Sandra_Vermaak_clean.pptx
@@ -2531,7 +2531,7 @@
         </p:nvSpPr>
         <p:spPr>
           <a:xfrm>
-            <a:off x="564185" y="338328"/>
+            <a:off x="548640" y="384048"/>
             <a:ext cx="11094415" cy="237744"/>
           </a:xfrm>
           <a:prstGeom prst="rect">
@@ -2609,7 +2609,7 @@
         </p:nvSpPr>
         <p:spPr>
           <a:xfrm>
-            <a:off x="500513" y="1315292"/>
+            <a:off x="548640" y="1315292"/>
             <a:ext cx="11094415" cy="1069848"/>
           </a:xfrm>
           <a:prstGeom prst="rect">
@@ -2670,17 +2670,14 @@
             </a:r>
           </a:p>
           <a:p>
-            <a:r>
-              <a:rPr lang="en-US" sz="1350" i="1" dirty="0">
-                <a:solidFill>
-                  <a:srgbClr val="2E7D68"/>
-                </a:solidFill>
-                <a:latin typeface="Calibri" pitchFamily="34" charset="0"/>
-                <a:ea typeface="Calibri" pitchFamily="34" charset="-122"/>
-                <a:cs typeface="Calibri" pitchFamily="34" charset="-120"/>
-              </a:rPr>
-              <a:t/>
-            </a:r>
+            <a:endParaRPr lang="en-US" sz="1350" i="1" dirty="0">
+              <a:solidFill>
+                <a:srgbClr val="2E7D68"/>
+              </a:solidFill>
+              <a:latin typeface="Calibri" pitchFamily="34" charset="0"/>
+              <a:ea typeface="Calibri" pitchFamily="34" charset="-122"/>
+              <a:cs typeface="Calibri" pitchFamily="34" charset="-120"/>
+            </a:endParaRPr>
           </a:p>
           <a:p>
             <a:pPr marL="0" indent="0">
@@ -2709,8 +2706,8 @@
         </p:nvSpPr>
         <p:spPr>
           <a:xfrm>
-            <a:off x="474285" y="2801914"/>
-            <a:ext cx="3484778" cy="2918380"/>
+            <a:off x="548640" y="2798064"/>
+            <a:ext cx="3483864" cy="2916936"/>
           </a:xfrm>
           <a:prstGeom prst="roundRect">
             <a:avLst>
@@ -2743,7 +2740,7 @@
         </p:nvSpPr>
         <p:spPr>
           <a:xfrm>
-            <a:off x="675453" y="2779776"/>
+            <a:off x="749808" y="2852928"/>
             <a:ext cx="420624" cy="420624"/>
           </a:xfrm>
           <a:prstGeom prst="ellipse">
@@ -2770,7 +2767,7 @@
         </p:nvSpPr>
         <p:spPr>
           <a:xfrm>
-            <a:off x="675453" y="2779776"/>
+            <a:off x="749808" y="2852928"/>
             <a:ext cx="420624" cy="420624"/>
           </a:xfrm>
           <a:prstGeom prst="rect">
@@ -2809,7 +2806,7 @@
         </p:nvSpPr>
         <p:spPr>
           <a:xfrm>
-            <a:off x="1260669" y="2825496"/>
+            <a:off x="1335024" y="2898648"/>
             <a:ext cx="2468880" cy="329184"/>
           </a:xfrm>
           <a:prstGeom prst="rect">
@@ -2848,7 +2845,7 @@
         </p:nvSpPr>
         <p:spPr>
           <a:xfrm>
-            <a:off x="794325" y="3291840"/>
+            <a:off x="868680" y="3383280"/>
             <a:ext cx="2843784" cy="868680"/>
           </a:xfrm>
           <a:prstGeom prst="rect">
@@ -2890,7 +2887,7 @@
         </p:nvSpPr>
         <p:spPr>
           <a:xfrm>
-            <a:off x="794325" y="4297680"/>
+            <a:off x="868680" y="4370832"/>
             <a:ext cx="2843784" cy="1005840"/>
           </a:xfrm>
           <a:prstGeom prst="rect">
@@ -2932,8 +2929,8 @@
         </p:nvSpPr>
         <p:spPr>
           <a:xfrm>
-            <a:off x="4353458" y="2801914"/>
-            <a:ext cx="3484778" cy="2918380"/>
+            <a:off x="4352544" y="2798064"/>
+            <a:ext cx="3483864" cy="2916936"/>
           </a:xfrm>
           <a:prstGeom prst="roundRect">
             <a:avLst>
@@ -2966,7 +2963,7 @@
         </p:nvSpPr>
         <p:spPr>
           <a:xfrm>
-            <a:off x="4554626" y="2779776"/>
+            <a:off x="4553712" y="2852928"/>
             <a:ext cx="420624" cy="420624"/>
           </a:xfrm>
           <a:prstGeom prst="ellipse">
@@ -2993,7 +2990,7 @@
         </p:nvSpPr>
         <p:spPr>
           <a:xfrm>
-            <a:off x="4554626" y="2779776"/>
+            <a:off x="4553712" y="2852928"/>
             <a:ext cx="420624" cy="420624"/>
           </a:xfrm>
           <a:prstGeom prst="rect">
@@ -3032,7 +3029,7 @@
         </p:nvSpPr>
         <p:spPr>
           <a:xfrm>
-            <a:off x="5139842" y="2825496"/>
+            <a:off x="5138928" y="2898648"/>
             <a:ext cx="2468880" cy="329184"/>
           </a:xfrm>
           <a:prstGeom prst="rect">
@@ -3071,7 +3068,7 @@
         </p:nvSpPr>
         <p:spPr>
           <a:xfrm>
-            <a:off x="4673498" y="3291840"/>
+            <a:off x="4672583" y="3383280"/>
             <a:ext cx="2843784" cy="868680"/>
           </a:xfrm>
           <a:prstGeom prst="rect">
@@ -3113,7 +3110,7 @@
         </p:nvSpPr>
         <p:spPr>
           <a:xfrm>
-            <a:off x="4673498" y="4297680"/>
+            <a:off x="4672583" y="4370832"/>
             <a:ext cx="2843784" cy="1005840"/>
           </a:xfrm>
           <a:prstGeom prst="rect">
@@ -3155,8 +3152,8 @@
         </p:nvSpPr>
         <p:spPr>
           <a:xfrm>
-            <a:off x="8158277" y="2796620"/>
-            <a:ext cx="3484778" cy="2918380"/>
+            <a:off x="8156448" y="2798064"/>
+            <a:ext cx="3483864" cy="2916936"/>
           </a:xfrm>
           <a:prstGeom prst="roundRect">
             <a:avLst>
@@ -3189,7 +3186,7 @@
         </p:nvSpPr>
         <p:spPr>
           <a:xfrm>
-            <a:off x="8359445" y="2779776"/>
+            <a:off x="8357616" y="2852928"/>
             <a:ext cx="420624" cy="420624"/>
           </a:xfrm>
           <a:prstGeom prst="ellipse">
@@ -3216,7 +3213,7 @@
         </p:nvSpPr>
         <p:spPr>
           <a:xfrm>
-            <a:off x="8359445" y="2779776"/>
+            <a:off x="8357616" y="2852928"/>
             <a:ext cx="420624" cy="420624"/>
           </a:xfrm>
           <a:prstGeom prst="rect">
@@ -3255,7 +3252,7 @@
         </p:nvSpPr>
         <p:spPr>
           <a:xfrm>
-            <a:off x="8944661" y="2825496"/>
+            <a:off x="8942832" y="2898648"/>
             <a:ext cx="2468880" cy="329184"/>
           </a:xfrm>
           <a:prstGeom prst="rect">
@@ -3294,7 +3291,7 @@
         </p:nvSpPr>
         <p:spPr>
           <a:xfrm>
-            <a:off x="8478317" y="3291840"/>
+            <a:off x="8476488" y="3383280"/>
             <a:ext cx="2843784" cy="868680"/>
           </a:xfrm>
           <a:prstGeom prst="rect">
@@ -3336,7 +3333,7 @@
         </p:nvSpPr>
         <p:spPr>
           <a:xfrm>
-            <a:off x="8478317" y="4297680"/>
+            <a:off x="8476488" y="4370832"/>
             <a:ext cx="2843784" cy="1005840"/>
           </a:xfrm>
           <a:prstGeom prst="rect">
@@ -3403,7 +3400,7 @@
                 <a:ea typeface="Calibri" pitchFamily="34" charset="-122"/>
                 <a:cs typeface="Calibri" pitchFamily="34" charset="-120"/>
               </a:rPr>
-              <a:t>Then I'd walk through real jobs with supervisors and planners, so the financial explanation matches what is happening on the ground.</a:t>
+              <a:t>Then I'd walk through jobs with the operational team so the financial explanation matches what is happening on the ground.</a:t>
             </a:r>
             <a:endParaRPr lang="en-US" sz="1100" dirty="0"/>
           </a:p>
@@ -3783,8 +3780,8 @@
         </p:nvSpPr>
         <p:spPr>
           <a:xfrm>
-            <a:off x="585216" y="3442063"/>
-            <a:ext cx="3393338" cy="1691640"/>
+            <a:off x="585216" y="3441801"/>
+            <a:ext cx="3392424" cy="1691640"/>
           </a:xfrm>
           <a:prstGeom prst="rect">
             <a:avLst/>
@@ -4006,8 +4003,8 @@
         </p:nvSpPr>
         <p:spPr>
           <a:xfrm>
-            <a:off x="4353458" y="3442063"/>
-            <a:ext cx="3393338" cy="1691640"/>
+            <a:off x="4390034" y="3441801"/>
+            <a:ext cx="3392424" cy="1691640"/>
           </a:xfrm>
           <a:prstGeom prst="rect">
             <a:avLst/>
@@ -4188,7 +4185,7 @@
                 <a:ea typeface="Cambria" pitchFamily="34" charset="-122"/>
                 <a:cs typeface="Cambria" pitchFamily="34" charset="-120"/>
               </a:rPr>
-              <a:t>Operational Buy In</a:t>
+              <a:t>Operational buy-in</a:t>
             </a:r>
             <a:endParaRPr lang="en-US" sz="1700" dirty="0"/>
           </a:p>
@@ -4202,8 +4199,8 @@
         </p:nvSpPr>
         <p:spPr>
           <a:xfrm>
-            <a:off x="8213446" y="3429000"/>
-            <a:ext cx="3393338" cy="1691640"/>
+            <a:off x="8194853" y="3441801"/>
+            <a:ext cx="3392424" cy="1691640"/>
           </a:xfrm>
           <a:prstGeom prst="rect">
             <a:avLst/>
@@ -4234,7 +4231,7 @@
                 <a:ea typeface="Calibri" pitchFamily="34" charset="-122"/>
                 <a:cs typeface="Calibri" pitchFamily="34" charset="-120"/>
               </a:rPr>
-              <a:t>Monthly sign-off with the service lead</a:t>
+              <a:t>Sign-off with the operations</a:t>
             </a:r>
             <a:endParaRPr lang="en-US" sz="1200" dirty="0"/>
           </a:p>
@@ -4258,7 +4255,7 @@
                 <a:ea typeface="Calibri" pitchFamily="34" charset="-122"/>
                 <a:cs typeface="Calibri" pitchFamily="34" charset="-120"/>
               </a:rPr>
-              <a:t>Quantify disagreement rather than settle it</a:t>
+              <a:t>Quantify disagreements</a:t>
             </a:r>
             <a:endParaRPr lang="en-US" sz="1200" dirty="0"/>
           </a:p>
@@ -4422,7 +4419,7 @@
         </p:nvSpPr>
         <p:spPr>
           <a:xfrm>
-            <a:off x="548640" y="658368"/>
+            <a:off x="545897" y="658368"/>
             <a:ext cx="11094415" cy="566928"/>
           </a:xfrm>
           <a:prstGeom prst="rect">
@@ -4435,9 +4432,6 @@
           <a:bodyPr wrap="square" lIns="0" tIns="0" rIns="0" bIns="0" rtlCol="0" anchor="ctr"/>
           <a:lstStyle/>
           <a:p>
-            <a:pPr marL="0" indent="0">
-              <a:buNone/>
-            </a:pPr>
             <a:r>
               <a:rPr lang="en-US" sz="3000" b="1" dirty="0">
                 <a:solidFill>
@@ -4447,7 +4441,7 @@
                 <a:ea typeface="Cambria" pitchFamily="34" charset="-122"/>
                 <a:cs typeface="Cambria" pitchFamily="34" charset="-120"/>
               </a:rPr>
-              <a:t>Act in order: protect first, then choose</a:t>
+              <a:t>Identify the risk and opportunities – escalate early</a:t>
             </a:r>
             <a:endParaRPr lang="en-US" sz="3000" dirty="0"/>
           </a:p>
@@ -4461,7 +4455,7 @@
         </p:nvSpPr>
         <p:spPr>
           <a:xfrm>
-            <a:off x="548640" y="1572768"/>
+            <a:off x="548640" y="1399032"/>
             <a:ext cx="420624" cy="420624"/>
           </a:xfrm>
           <a:prstGeom prst="ellipse">
@@ -4488,7 +4482,7 @@
         </p:nvSpPr>
         <p:spPr>
           <a:xfrm>
-            <a:off x="548640" y="1572768"/>
+            <a:off x="548640" y="1362456"/>
             <a:ext cx="420624" cy="420624"/>
           </a:xfrm>
           <a:prstGeom prst="rect">
@@ -4527,7 +4521,7 @@
         </p:nvSpPr>
         <p:spPr>
           <a:xfrm>
-            <a:off x="1115568" y="1554480"/>
+            <a:off x="1115568" y="1381341"/>
             <a:ext cx="5212080" cy="310896"/>
           </a:xfrm>
           <a:prstGeom prst="rect">
@@ -4565,7 +4559,7 @@
         </p:nvSpPr>
         <p:spPr>
           <a:xfrm>
-            <a:off x="1115568" y="1901952"/>
+            <a:off x="1115568" y="1692237"/>
             <a:ext cx="5212080" cy="566928"/>
           </a:xfrm>
           <a:prstGeom prst="rect">
@@ -4589,11 +4583,6 @@
               <a:t>Predefined rates
 Monetary threshold for repairs vs capex</a:t>
             </a:r>
-            <a:r>
-              <a:rPr lang="en-US" sz="1200" dirty="0"/>
-              <a:t/>
-            </a:r>
-            <a:endParaRPr lang="en-GB" sz="1200" dirty="0"/>
           </a:p>
         </p:txBody>
       </p:sp>
@@ -4750,7 +4739,7 @@
                 <a:latin typeface="Calibri" pitchFamily="34" charset="0"/>
                 <a:cs typeface="Calibri" pitchFamily="34" charset="-120"/>
               </a:rPr>
-              <a:t>Fixed scope of work - scope creep</a:t>
+              <a:t>Fixed scope of work – guard against scope creep</a:t>
             </a:r>
             <a:endParaRPr lang="en-US" sz="1200" dirty="0"/>
           </a:p>
@@ -4909,7 +4898,7 @@
                 <a:latin typeface="Calibri" pitchFamily="34" charset="0"/>
                 <a:cs typeface="Calibri" pitchFamily="34" charset="-120"/>
               </a:rPr>
-              <a:t>Variance to budget - causal</a:t>
+              <a:t>Variance to budget – causal</a:t>
             </a:r>
             <a:endParaRPr lang="en-US" sz="1200" dirty="0"/>
           </a:p>
@@ -5678,7 +5667,7 @@
                 <a:ea typeface="Cambria" pitchFamily="34" charset="-122"/>
                 <a:cs typeface="Cambria" pitchFamily="34" charset="-120"/>
               </a:rPr>
-              <a:t>Identify the risk and opportunities - escalate early</a:t>
+              <a:t>Partnering through trust</a:t>
             </a:r>
             <a:endParaRPr lang="en-US" sz="3000" dirty="0"/>
           </a:p>
@@ -6265,7 +6254,7 @@
                 <a:ea typeface="Calibri" pitchFamily="34" charset="-122"/>
                 <a:cs typeface="Calibri" pitchFamily="34" charset="-120"/>
               </a:rPr>
-              <a:t>Repairs is largely revenue spend, so an overspend comes off operating surplus – which feeds interest cover and covenant headroom. </a:t>
+              <a:t>Repairs is largely revenue spend, so an overspend comes off operating surplus – which feeds interest cover and covenant headroom.</a:t>
             </a:r>
             <a:endParaRPr lang="en-US" sz="1300" dirty="0"/>
           </a:p>
@@ -6437,17 +6426,6 @@
                 <a:cs typeface="Calibri" pitchFamily="34" charset="-120"/>
               </a:rPr>
               <a:t>Identify the gap, provide a recommendation and the alternative. Be clear on the consequence of doing nothing.</a:t>
-            </a:r>
-            <a:r>
-              <a:rPr lang="en-US" sz="1350" b="1" dirty="0">
-                <a:solidFill>
-                  <a:srgbClr val="16211E"/>
-                </a:solidFill>
-                <a:latin typeface="Calibri" pitchFamily="34" charset="0"/>
-                <a:ea typeface="Calibri" pitchFamily="34" charset="-122"/>
-                <a:cs typeface="Calibri" pitchFamily="34" charset="-120"/>
-              </a:rPr>
-              <a:t/>
             </a:r>
             <a:endParaRPr lang="en-US" sz="1350" dirty="0"/>
           </a:p>
@@ -7079,7 +7057,7 @@
         </p:nvSpPr>
         <p:spPr>
           <a:xfrm>
-            <a:off x="548640" y="4343400"/>
+            <a:off x="548640" y="4736592"/>
             <a:ext cx="11091672" cy="292608"/>
           </a:xfrm>
           <a:prstGeom prst="rect">

</xml_diff>

<commit_message>
Rewrite the speaker notes to match the current slides
The notes still described the earlier structure: slide 5's walked
through four steps beginning 'First, protect' against a slide showing
five beginning with Planning, and slides 3, 4, 6 and 7 had all moved on
too. All seven are rewritten to follow the slides as they now stand.

They use Sandra's own terms from the slides (GL deep dive, prior year,
FYF, run rate, causal, scope creep, safety stock, buy-in) and cover the
points she added since the last version: the one-off versus trend test,
the single inflation assumption applied across finance areas,
predefined rates and the repairs/capex threshold, safety stock, and
productivity in the measures.

1,307 words, about 9.7 minutes at normal pace. The PACE markers are
replaced with plain timing cues. Slide content is untouched.

Co-Authored-By: Claude Opus 5 <noreply@anthropic.com>
Claude-Session: https://claude.ai/code/session_01USX9SeNWtCVt7CViGP813v
</commit_message>
<xml_diff>
--- a/briefings/Codi_Presentation_Sandra_Vermaak_clean.pptx
+++ b/briefings/Codi_Presentation_Sandra_Vermaak_clean.pptx
@@ -288,10 +288,19 @@
           <a:lstStyle/>
           <a:p>
             <a:r>
-              <a:rPr lang="en-US" dirty="0"/>
-              <a:t>PACE 0:45  ·  Seven slides, ten minutes.
-Thank you for seeing me. I've got ten minutes, so I'll take your five questions in order: how I'd work out what's driving the overspend, how I'd rebuild the forecast with the budget holders, what I'd actually do about it, how I'd tell senior leaders, and what I'd track afterwards.
-One thing up front. I don't know your systems or your numbers yet, so this is how I'd approach it rather than a view on how things work here. Where I've used a figure it's illustrative, and I'll say so.</a:t>
+              <a:t>[45 sec · 0:45 elapsed]</a:t>
+            </a:r>
+          </a:p>
+          <a:p/>
+          <a:p>
+            <a:r>
+              <a:t>Thank you for seeing me. I've got ten minutes, so I'll take your five questions in order: how I'd work out what's driving the overspend, how I'd rebuild the forecast with the budget holders, what I'd actually do about it, how I'd communicate it, and what I'd track afterwards.</a:t>
+            </a:r>
+          </a:p>
+          <a:p/>
+          <a:p>
+            <a:r>
+              <a:t>One thing up front. I don't know your systems or your numbers yet, so this is how I'd approach it rather than a view on how things work here. Where I've used a figure it's illustrative, and I'll say so.</a:t>
             </a:r>
           </a:p>
         </p:txBody>
@@ -377,12 +386,37 @@
           <a:lstStyle/>
           <a:p>
             <a:r>
-              <a:rPr lang="en-US" dirty="0"/>
-              <a:t>PACE 1:20  ·  Running total 2:05.
-Before I can explain a variance I need to know what is actually in the budget. A hundred million across about twenty-five thousand homes is roughly four thousand pounds a home. That is more than responsive repairs alone would cost, so the budget must also be carrying cyclical work, compliance and planned or major works.
-That matters for two reasons. These things behave differently. Responsive is demand-led and hard to predict, compliance is effectively fixed, planned work is programme-driven. An average across all of them hides what is going on. And they sit on different sides of the revenue and capital line, and only the revenue side hits the surplus.
-So the first thing I would do is agree with the team exactly what sits in the number, and where that line is drawn. Reclassifying spend is not a saving, and I would want to be sure that none of the reported position depends on it.
-[Note] The £100m is the scenario you gave me; the per-home figure is my own arithmetic. The categories are illustrative.</a:t>
+              <a:t>[1 min 15 · 2:00 elapsed]</a:t>
+            </a:r>
+          </a:p>
+          <a:p/>
+          <a:p>
+            <a:r>
+              <a:t>Before I can explain a variance I need to know what's actually in the number. A hundred million across roughly twenty-five thousand homes is about four thousand pounds a home. That's more than responsive repairs alone would cost, so the budget must also be carrying cyclical work, compliance, and planned and major works.</a:t>
+            </a:r>
+          </a:p>
+          <a:p/>
+          <a:p>
+            <a:r>
+              <a:t>That matters for two reasons. They behave differently. Responsive is demand-led and hard to forecast, cyclical is predictable, compliance is non-negotiable, and planned work is programme-driven. An average across all four hides what's going on.</a:t>
+            </a:r>
+          </a:p>
+          <a:p/>
+          <a:p>
+            <a:r>
+              <a:t>And they sit on different sides of the revenue and capital line. Only the revenue side hits the surplus.</a:t>
+            </a:r>
+          </a:p>
+          <a:p/>
+          <a:p>
+            <a:r>
+              <a:t>So the first thing I'd do is agree with the team exactly what sits in the number, and where the threshold between a repair and capex is drawn. Reclassifying spend isn't a saving, and I'd want to be sure none of the reported position depends on it.</a:t>
+            </a:r>
+          </a:p>
+          <a:p/>
+          <a:p>
+            <a:r>
+              <a:t>[Note] The £100m is the scenario you gave me. The per-home figure is my own arithmetic and the categories are illustrative.</a:t>
             </a:r>
           </a:p>
         </p:txBody>
@@ -468,13 +502,55 @@
           <a:lstStyle/>
           <a:p>
             <a:r>
-              <a:rPr lang="en-US" dirty="0"/>
-              <a:t>PACE 2:05  ·  Running total 4:10.
-Before deciding anything I would want to know what is actually driving it, and I would work through it in a set order.
-First, is it real? A lot of apparent overspends turn out to be timing. Work done but not yet invoiced, accruals in the wrong period, jobs coded to the wrong budget, or a programme simply running ahead of its phasing. I would rule that out before raising an alarm, because getting that wrong once costs you credibility for the rest of the year.
-Once I am satisfied it is real, I would split it three ways. Volume: are we doing more jobs than we planned for? Price: is each job costing more than we assumed, and is that labour, materials, or more work going to contractors? Mix: is the work different – more emergencies, more complex jobs, or particular property types and areas driving it?
-That split matters because each one leads somewhere different. A volume problem is a demand and capacity conversation. A price problem is a procurement and rates conversation. A mix problem usually means the assumptions in the budget were wrong, and that affects next year as well as this one.
-And I would not do this from a spreadsheet on its own. I would go through real jobs with the supervisors and planners, so that whatever I end up telling the board matches what is actually happening on the ground.</a:t>
+              <a:t>[2 min · 4:00 elapsed]</a:t>
+            </a:r>
+          </a:p>
+          <a:p/>
+          <a:p>
+            <a:r>
+              <a:t>Before I decide anything I want to know what's actually driving it, and I'd work through it in order.</a:t>
+            </a:r>
+          </a:p>
+          <a:p/>
+          <a:p>
+            <a:r>
+              <a:t>First, is it real? A lot of apparent overspends turn out to be something else. Coding errors, phasing, accruals, adjustments, or the way costs have been allocated. I'd do a GL deep dive before raising any alarm, because getting that wrong once costs you credibility for the rest of the year.</a:t>
+            </a:r>
+          </a:p>
+          <a:p/>
+          <a:p>
+            <a:r>
+              <a:t>Then, is it a one-off or an emerging trend? I'd compare actuals to prior year as well as to forecast, and ask whether the forecast assumptions themselves have changed. A single bad month is a different conversation from a run rate that has moved.</a:t>
+            </a:r>
+          </a:p>
+          <a:p/>
+          <a:p>
+            <a:r>
+              <a:t>Once I'm satisfied it's real and it's a trend, I'd split the variance three ways.</a:t>
+            </a:r>
+          </a:p>
+          <a:p/>
+          <a:p>
+            <a:r>
+              <a:t>Volume. Are we simply doing more jobs than the budget assumed? Job numbers by type against budget and against last year, the backlog, seasonality, and anything that's changed in demand.</a:t>
+            </a:r>
+          </a:p>
+          <a:p/>
+          <a:p>
+            <a:r>
+              <a:t>Price. Is each job costing more? Cost per job on like-for-like work, labour and material rates, and how much more is going to contractors rather than our own teams.</a:t>
+            </a:r>
+          </a:p>
+          <a:p/>
+          <a:p>
+            <a:r>
+              <a:t>Mix. Is the work different, or more complicated? Job types and complexity, emergency against planned, and which properties or areas are driving it. Productivity sits here too, because the same job taking longer is a mix and productivity problem, not a price one.</a:t>
+            </a:r>
+          </a:p>
+          <a:p/>
+          <a:p>
+            <a:r>
+              <a:t>Each of those leads somewhere different, which is why I wouldn't lump them together. And I wouldn't do it from a spreadsheet alone. I'd walk through real jobs with the operational team, so what I end up telling the board matches what's happening on the ground.</a:t>
             </a:r>
           </a:p>
         </p:txBody>
@@ -560,12 +636,37 @@
           <a:lstStyle/>
           <a:p>
             <a:r>
-              <a:rPr lang="en-US" dirty="0"/>
-              <a:t>PACE 1:35  ·  Running total 5:45.
-The forecast has to be built with the budget holders, not sent to them. I bring the structure and the challenge; they own the assumptions about demand, capacity and what they can realistically deliver. If they have not helped shape it they will not stand behind it, and a forecast nobody stands behind gets ignored.
-The mechanics are actuals, plus what we are already committed to, plus the remaining work at a realistic cost per job. For responsive that is expected job numbers by type against an evidenced unit cost, allowing for seasonality and backlog. For planned work it is what is left at contract rates, against dates the team actually believes. I would be careful with open commitments so nothing is counted twice – that is the easiest mistake to make.
-I would write down who owns each significant assumption and how confident they are, and run a downside as well as a base case, so we can see the range and which two or three things really move the answer.
-One thing I would hold firmly. Show the forecast before mitigation. Only actions that are owned, dated and realistic come off it, and everything else is listed separately as an opportunity. A savings target is not a forecast.</a:t>
+              <a:t>[1 min 35 · 5:35 elapsed]</a:t>
+            </a:r>
+          </a:p>
+          <a:p/>
+          <a:p>
+            <a:r>
+              <a:t>The forecast has to be built with the people who own the budget, not sent to them.</a:t>
+            </a:r>
+          </a:p>
+          <a:p/>
+          <a:p>
+            <a:r>
+              <a:t>Mechanically it's actuals, plus what we're already committed to, plus the remaining work at a realistic cost. That gives the full year forecast.</a:t>
+            </a:r>
+          </a:p>
+          <a:p/>
+          <a:p>
+            <a:r>
+              <a:t>Three things make it credible. First, agree the plan. A realistic plan for the year with detailed timing, the capacity and manpower actually available, the work mix and complexity, and the contract rates and variations we already know about. A plan that assumes capacity we haven't got isn't a forecast, it's a wish.</a:t>
+            </a:r>
+          </a:p>
+          <a:p/>
+          <a:p>
+            <a:r>
+              <a:t>Second, cost the work honestly. I'd use run rate as a guide rather than a rule, and agree one inflationary assumption applied consistently across all finance areas. Different teams quietly using different inflation is one of the easiest ways for a group position to stop adding up. I'd build the base case before adjustments, then set out the overall picture and get the actions identified and embedded in it.</a:t>
+            </a:r>
+          </a:p>
+          <a:p/>
+          <a:p>
+            <a:r>
+              <a:t>Third, operational buy-in. Sign-off with the operations, and where we disagree I'd quantify the difference rather than argue it out. A number the operation hasn't signed won't survive its first challenge.</a:t>
             </a:r>
           </a:p>
         </p:txBody>
@@ -651,14 +752,49 @@
           <a:lstStyle/>
           <a:p>
             <a:r>
-              <a:rPr lang="en-US" dirty="0"/>
-              <a:t>PACE 1:35  ·  Running total 7:20.
-I would work through the options in a deliberate order.
-First, protect. Safety, compliance and statutory response times are ring-fenced. Slowing those down is not a saving. It comes back as disrepair cost, and it is the wrong thing to do to somebody living in the home.
-Second, get more out of the capacity we already have. Where there are in-house teams, the cheapest saving available is making them more productive: the right diagnosis, the right trade first time, materials on the van, appointments that stick. But I would only call that a cash saving if it actually reduces paid hours or takes work off a contractor. If it does not, it is spare capacity or cost avoided later, and I would report it that way.
-Third, external spend. Working with procurement on call-off discipline, checking variations are valid, and testing rates on genuinely comparable work.
-Fourth, and only then, rephasing discretionary planned work with the asset and service leads.
-And I would be clear about the knock-on effect, because this is where in-year savings destroy value. Deferring planned work usually increases responsive demand later, and it moves spend that would have been capitalised into revenue, which hits the surplus rather than just moving between years. Every action needs an owner, a date, a cost to deliver it and a benefit we can evidence.</a:t>
+              <a:t>[1 min 45 · 7:20 elapsed]</a:t>
+            </a:r>
+          </a:p>
+          <a:p/>
+          <a:p>
+            <a:r>
+              <a:t>Then the actions. I'd work through them in a deliberate order, and raise the risks early rather than at year end.</a:t>
+            </a:r>
+          </a:p>
+          <a:p/>
+          <a:p>
+            <a:r>
+              <a:t>Planning first. Properly understanding the nature, volume and complexity of the planned work, with predefined rates and a clear monetary threshold for what's a repair and what's capex. Most of the value is won here, before anything is spent.</a:t>
+            </a:r>
+          </a:p>
+          <a:p/>
+          <a:p>
+            <a:r>
+              <a:t>One boundary before anything else, though. Safety issues, compliance and statutory response times can't be cut. That is not where savings come from.</a:t>
+            </a:r>
+          </a:p>
+          <a:p/>
+          <a:p>
+            <a:r>
+              <a:t>Second, use the capacity we already have. Productivity, first-time fix, and scheduling across the in-house team, with a fixed scope of work to guard against scope creep. I'd also keep an eye on safety stock, because running materials too lean means paying over the odds the moment something runs out.</a:t>
+            </a:r>
+          </a:p>
+          <a:p/>
+          <a:p>
+            <a:r>
+              <a:t>Third, challenge additional spend that isn't in the budget. Checking variations, testing rates on like-for-like work, and understanding variance to budget on a causal basis rather than just reporting the number. I'd also be watching for changes to the assumptions we built the forecast on.</a:t>
+            </a:r>
+          </a:p>
+          <a:p/>
+          <a:p>
+            <a:r>
+              <a:t>Fourth, highlight risks. Identify any offsetting opportunities and raise them early, so actions can actually be agreed. A risk raised late leaves no options.</a:t>
+            </a:r>
+          </a:p>
+          <a:p/>
+          <a:p>
+            <a:r>
+              <a:t>And only then, fifth, rephase. Discretionary planned work only. That's a timing benefit rather than a saving, and I'd say so rather than let it be counted as one.</a:t>
             </a:r>
           </a:p>
         </p:txBody>
@@ -744,11 +880,37 @@
           <a:lstStyle/>
           <a:p>
             <a:r>
-              <a:rPr lang="en-US" dirty="0"/>
-              <a:t>PACE 1:25  ·  Running total 8:45.
-I would tell senior leaders as soon as there is a credible sign of a material problem, and be clear about what I know as against what I am still checking. I would not wait for a tidy month-end pack, because the information loses value faster than it gains accuracy.
-The report itself is a bridge. Approved budget, to the latest forecast, to the mitigations we have actually agreed, to the gap that is left, with a downside case and the movement since last time. One page. The decision I need, what I recommend, the alternative, and what happens if we do nothing.
-What I would avoid is presenting it as just a budget variance. Repairs is mostly revenue spend, so an overspend comes straight off the operating surplus, and that feeds interest cover and covenant headroom. And in practical terms, money spent unplanned on reactive work is money that is not available for planned works or for new homes. That is the trade-off leadership is really being asked to make, so that is how I would frame it – and it is why I would want treasury and corporate finance in the conversation early rather than at the end.</a:t>
+              <a:t>[1 min 25 · 8:45 elapsed]</a:t>
+            </a:r>
+          </a:p>
+          <a:p/>
+          <a:p>
+            <a:r>
+              <a:t>Then communicating it, and for me that's partnering rather than reporting.</a:t>
+            </a:r>
+          </a:p>
+          <a:p/>
+          <a:p>
+            <a:r>
+              <a:t>The report itself is a bridge. Approved budget, to the latest forecast, to the mitigations we've agreed, to the gap that remains.</a:t>
+            </a:r>
+          </a:p>
+          <a:p/>
+          <a:p>
+            <a:r>
+              <a:t>But I wouldn't present it as just a budget variance, because it isn't one. Repairs is largely revenue spend, so an overspend comes off operating surplus, and that feeds interest cover and covenant headroom. And money spent unplanned on reactive work is money that isn't available for planned works and new homes. That's the trade-off leadership is really being asked to make, so that's how I'd frame it.</a:t>
+            </a:r>
+          </a:p>
+          <a:p/>
+          <a:p>
+            <a:r>
+              <a:t>On how I'd do it. Be timely, because identifying risks late leaves little opportunity to correct course. Be honest, including when the news is bad or the number has moved against me. Be factual, so the conversation is about the decision rather than about whose figures are right. And be the partner, not the person who turns up at year end with a number and no options.</a:t>
+            </a:r>
+          </a:p>
+          <a:p/>
+          <a:p>
+            <a:r>
+              <a:t>So: identify the gap, provide a recommendation and the alternative, and be clear on the consequence of doing nothing.</a:t>
             </a:r>
           </a:p>
         </p:txBody>
@@ -834,12 +996,37 @@
           <a:lstStyle/>
           <a:p>
             <a:r>
-              <a:rPr lang="en-US" dirty="0"/>
-              <a:t>PACE 1:15  ·  Running total 10:00.
-Last, measurement. I would agree a short set with the teams, each with a definition, a baseline, an owner and a point where we escalate. The test of a dashboard is whether it changes what somebody does on Monday morning.
-On the money: the gap and how it has moved, whether the savings we agreed have actually landed, the capital and revenue split, and cost per job adjusted for the mix of work. That adjustment matters, because an average cost can fall simply because the team did easier jobs that month, and I would not let that be reported as efficiency.
-On the service: outstanding safety and compliance work, first-time fix, jobs per operative, how old the backlog is, and repeat contact. Those tell you early if a saving is coming out of the resident rather than out of the cost.
-What I would want a year in is a number the operation recognises as theirs, a forecast that stops moving, and a resident who does not have to ring twice. Thank you – happy to take questions.</a:t>
+              <a:t>[1 min 15 · 10:00 elapsed]</a:t>
+            </a:r>
+          </a:p>
+          <a:p/>
+          <a:p>
+            <a:r>
+              <a:t>Finally, measurement. A short set agreed with the teams, each with a definition, a baseline, an owner and a point where we escalate. The test of a dashboard is whether it changes what somebody does on Monday morning.</a:t>
+            </a:r>
+          </a:p>
+          <a:p/>
+          <a:p>
+            <a:r>
+              <a:t>On the money: the gap and how it's moved since last time, whether the savings we expected have actually landed, the split between capital and revenue, cost per job adjusted for the mix of work, and productivity. That mix adjustment matters, because an average cost can fall simply because the team did easier jobs that month, and I wouldn't let that be reported as efficiency.</a:t>
+            </a:r>
+          </a:p>
+          <a:p/>
+          <a:p>
+            <a:r>
+              <a:t>On service and residents: outstanding safety and compliance work, first-time fix and repeat visits, jobs per operative, how old the backlog is, and satisfaction and repeat contact. Those tell you early if a saving is being taken out of the resident rather than out of the cost.</a:t>
+            </a:r>
+          </a:p>
+          <a:p/>
+          <a:p>
+            <a:r>
+              <a:t>A weekly look at exceptions with the operational team, a monthly signed-off position, and anything safety-related goes straight up.</a:t>
+            </a:r>
+          </a:p>
+          <a:p/>
+          <a:p>
+            <a:r>
+              <a:t>Thank you. I'm happy to take questions.</a:t>
             </a:r>
           </a:p>
         </p:txBody>

</xml_diff>